<commit_message>
coiding in agentic ai
</commit_message>
<xml_diff>
--- a/savingfolder_output/genearted/MASTER.pptx
+++ b/savingfolder_output/genearted/MASTER.pptx
@@ -3158,7 +3158,7 @@
                   <a:srgbClr val="FFDF80"/>
                 </a:solidFill>
               </a:rPr>
-              <a:t>Mastery of the History and Evolution of \Books</a:t>
+              <a:t>Mastery of Books</a:t>
             </a:r>
           </a:p>
         </p:txBody>
@@ -3311,7 +3311,7 @@
               </a:defRPr>
             </a:pPr>
             <a:r>
-              <a:t>• Deep dive into the History and Evolution of \Books history.</a:t>
+              <a:t>• Deep dive into Books history.</a:t>
             </a:r>
           </a:p>
           <a:p>
@@ -3335,7 +3335,7 @@
               </a:defRPr>
             </a:pPr>
             <a:r>
-              <a:t>• Social and economic significance of the History and Evolution of \Books.</a:t>
+              <a:t>• Social and economic significance of Books.</a:t>
             </a:r>
           </a:p>
           <a:p>
@@ -3529,7 +3529,7 @@
               </a:defRPr>
             </a:pPr>
             <a:r>
-              <a:t>• Deep dive into the History and Evolution of \Books history.</a:t>
+              <a:t>• Deep dive into Books history.</a:t>
             </a:r>
           </a:p>
           <a:p>
@@ -3553,7 +3553,7 @@
               </a:defRPr>
             </a:pPr>
             <a:r>
-              <a:t>• Social and economic significance of the History and Evolution of \Books.</a:t>
+              <a:t>• Social and economic significance of Books.</a:t>
             </a:r>
           </a:p>
           <a:p>
@@ -3747,7 +3747,7 @@
               </a:defRPr>
             </a:pPr>
             <a:r>
-              <a:t>• Deep dive into the History and Evolution of \Books history.</a:t>
+              <a:t>• Deep dive into Books history.</a:t>
             </a:r>
           </a:p>
           <a:p>
@@ -3771,7 +3771,7 @@
               </a:defRPr>
             </a:pPr>
             <a:r>
-              <a:t>• Social and economic significance of the History and Evolution of \Books.</a:t>
+              <a:t>• Social and economic significance of Books.</a:t>
             </a:r>
           </a:p>
           <a:p>
@@ -3965,7 +3965,7 @@
               </a:defRPr>
             </a:pPr>
             <a:r>
-              <a:t>• Deep dive into the History and Evolution of \Books history.</a:t>
+              <a:t>• Deep dive into Books history.</a:t>
             </a:r>
           </a:p>
           <a:p>
@@ -3989,7 +3989,7 @@
               </a:defRPr>
             </a:pPr>
             <a:r>
-              <a:t>• Social and economic significance of the History and Evolution of \Books.</a:t>
+              <a:t>• Social and economic significance of Books.</a:t>
             </a:r>
           </a:p>
           <a:p>
@@ -4183,7 +4183,7 @@
               </a:defRPr>
             </a:pPr>
             <a:r>
-              <a:t>• Deep dive into the History and Evolution of \Books history.</a:t>
+              <a:t>• Deep dive into Books history.</a:t>
             </a:r>
           </a:p>
           <a:p>
@@ -4207,7 +4207,7 @@
               </a:defRPr>
             </a:pPr>
             <a:r>
-              <a:t>• Social and economic significance of the History and Evolution of \Books.</a:t>
+              <a:t>• Social and economic significance of Books.</a:t>
             </a:r>
           </a:p>
           <a:p>
@@ -4401,7 +4401,7 @@
               </a:defRPr>
             </a:pPr>
             <a:r>
-              <a:t>• Deep dive into the History and Evolution of \Books history.</a:t>
+              <a:t>• Deep dive into Books history.</a:t>
             </a:r>
           </a:p>
           <a:p>
@@ -4425,7 +4425,7 @@
               </a:defRPr>
             </a:pPr>
             <a:r>
-              <a:t>• Social and economic significance of the History and Evolution of \Books.</a:t>
+              <a:t>• Social and economic significance of Books.</a:t>
             </a:r>
           </a:p>
           <a:p>

</xml_diff>